<commit_message>
minor improvements and adjustments to ppt
</commit_message>
<xml_diff>
--- a/Atlanta-Year-One.pptx
+++ b/Atlanta-Year-One.pptx
@@ -2,30 +2,30 @@
 <file path=ppt/presentation.xml><?xml version="1.0" encoding="utf-8"?>
 <p:presentation xmlns:p="http://schemas.openxmlformats.org/presentationml/2006/main">
   <p:sldMasterIdLst>
-    <p:sldMasterId xmlns:r="http://schemas.openxmlformats.org/officeDocument/2006/relationships" id="2147483648" r:id="Ra3049e645ee24f1d"/>
+    <p:sldMasterId xmlns:r="http://schemas.openxmlformats.org/officeDocument/2006/relationships" id="2147483648" r:id="R6bd9f0febb504409"/>
   </p:sldMasterIdLst>
   <p:notesMasterIdLst>
-    <p:notesMasterId xmlns:r="http://schemas.openxmlformats.org/officeDocument/2006/relationships" r:id="R87c4df636a9a49a0"/>
+    <p:notesMasterId xmlns:r="http://schemas.openxmlformats.org/officeDocument/2006/relationships" r:id="Rbe705b13b7614e0f"/>
   </p:notesMasterIdLst>
   <p:sldIdLst>
-    <p:sldId xmlns:r="http://schemas.openxmlformats.org/officeDocument/2006/relationships" id="256" r:id="R0b330e5d92574244"/>
-    <p:sldId xmlns:r="http://schemas.openxmlformats.org/officeDocument/2006/relationships" id="257" r:id="Rf3ba3583f57e4de9"/>
-    <p:sldId xmlns:r="http://schemas.openxmlformats.org/officeDocument/2006/relationships" id="258" r:id="Rf0343957be004825"/>
-    <p:sldId xmlns:r="http://schemas.openxmlformats.org/officeDocument/2006/relationships" id="259" r:id="R634fdce2f16d4afb"/>
-    <p:sldId xmlns:r="http://schemas.openxmlformats.org/officeDocument/2006/relationships" id="260" r:id="Rcccfa80b26484195"/>
-    <p:sldId xmlns:r="http://schemas.openxmlformats.org/officeDocument/2006/relationships" id="261" r:id="R823b1c2b42444df2"/>
-    <p:sldId xmlns:r="http://schemas.openxmlformats.org/officeDocument/2006/relationships" id="262" r:id="Ra753b82f12204d7f"/>
-    <p:sldId xmlns:r="http://schemas.openxmlformats.org/officeDocument/2006/relationships" id="263" r:id="Rfc95be7c807248a9"/>
-    <p:sldId xmlns:r="http://schemas.openxmlformats.org/officeDocument/2006/relationships" id="264" r:id="R5ef74f0335bc4f0b"/>
-    <p:sldId xmlns:r="http://schemas.openxmlformats.org/officeDocument/2006/relationships" id="265" r:id="R0fa5b39775a54721"/>
-    <p:sldId xmlns:r="http://schemas.openxmlformats.org/officeDocument/2006/relationships" id="266" r:id="R5efa06d9c49c4ba9"/>
-    <p:sldId xmlns:r="http://schemas.openxmlformats.org/officeDocument/2006/relationships" id="267" r:id="R839a01a57f9845f9"/>
-    <p:sldId xmlns:r="http://schemas.openxmlformats.org/officeDocument/2006/relationships" id="268" r:id="R872ecc8650144e14"/>
-    <p:sldId xmlns:r="http://schemas.openxmlformats.org/officeDocument/2006/relationships" id="269" r:id="Ra43929f5e9b84755"/>
-    <p:sldId xmlns:r="http://schemas.openxmlformats.org/officeDocument/2006/relationships" id="270" r:id="Re8287a90faec4024"/>
-    <p:sldId xmlns:r="http://schemas.openxmlformats.org/officeDocument/2006/relationships" id="271" r:id="R546eb7e0aa014800"/>
-    <p:sldId xmlns:r="http://schemas.openxmlformats.org/officeDocument/2006/relationships" id="272" r:id="R4371a39048ce40db"/>
-    <p:sldId xmlns:r="http://schemas.openxmlformats.org/officeDocument/2006/relationships" id="273" r:id="R2050910283e842e8"/>
+    <p:sldId xmlns:r="http://schemas.openxmlformats.org/officeDocument/2006/relationships" id="256" r:id="R56f5be3b8d844fd7"/>
+    <p:sldId xmlns:r="http://schemas.openxmlformats.org/officeDocument/2006/relationships" id="257" r:id="Reb83be51144a41c1"/>
+    <p:sldId xmlns:r="http://schemas.openxmlformats.org/officeDocument/2006/relationships" id="258" r:id="R2b4e3c2746444b7d"/>
+    <p:sldId xmlns:r="http://schemas.openxmlformats.org/officeDocument/2006/relationships" id="259" r:id="Rda2ae26436d24c74"/>
+    <p:sldId xmlns:r="http://schemas.openxmlformats.org/officeDocument/2006/relationships" id="260" r:id="Radfc90f5b03c4979"/>
+    <p:sldId xmlns:r="http://schemas.openxmlformats.org/officeDocument/2006/relationships" id="261" r:id="R57fb35ba3d48415d"/>
+    <p:sldId xmlns:r="http://schemas.openxmlformats.org/officeDocument/2006/relationships" id="262" r:id="Refcd1f5a2b9e4505"/>
+    <p:sldId xmlns:r="http://schemas.openxmlformats.org/officeDocument/2006/relationships" id="263" r:id="Rf1bf4ccc80f042b1"/>
+    <p:sldId xmlns:r="http://schemas.openxmlformats.org/officeDocument/2006/relationships" id="264" r:id="Ra430958182a94501"/>
+    <p:sldId xmlns:r="http://schemas.openxmlformats.org/officeDocument/2006/relationships" id="265" r:id="R8db5e89c80a644ce"/>
+    <p:sldId xmlns:r="http://schemas.openxmlformats.org/officeDocument/2006/relationships" id="266" r:id="R4ece96888c664547"/>
+    <p:sldId xmlns:r="http://schemas.openxmlformats.org/officeDocument/2006/relationships" id="267" r:id="R6244a7efe8dd4fd2"/>
+    <p:sldId xmlns:r="http://schemas.openxmlformats.org/officeDocument/2006/relationships" id="268" r:id="R6a6b3da78acc47bc"/>
+    <p:sldId xmlns:r="http://schemas.openxmlformats.org/officeDocument/2006/relationships" id="269" r:id="R75651c9d91164301"/>
+    <p:sldId xmlns:r="http://schemas.openxmlformats.org/officeDocument/2006/relationships" id="270" r:id="Rcc10ac6851a44455"/>
+    <p:sldId xmlns:r="http://schemas.openxmlformats.org/officeDocument/2006/relationships" id="271" r:id="R152eb10960584a8a"/>
+    <p:sldId xmlns:r="http://schemas.openxmlformats.org/officeDocument/2006/relationships" id="272" r:id="R929c159a50d14a06"/>
+    <p:sldId xmlns:r="http://schemas.openxmlformats.org/officeDocument/2006/relationships" id="273" r:id="R3ab27af1d8664f92"/>
   </p:sldIdLst>
   <p:sldSz cx="12192000" cy="6858000"/>
   <p:notesSz cx="6858000" cy="9144000"/>
@@ -462,21 +462,6 @@
               <a:t>I joined Atlanta as a junior frontend developer with internship experience. Over this period, my role expanded into complete frontend ownership, system design, stakeholder demonstrations and supporting other developers. This presentation focuses on the work I contributed and the value it enabled for Atlanta.</a:t>
             </a:r>
           </a:p>
-          <a:p xmlns:a="http://schemas.openxmlformats.org/drawingml/2006/main">
-            <a:r>
-              <a:t/>
-            </a:r>
-          </a:p>
-          <a:p xmlns:a="http://schemas.openxmlformats.org/drawingml/2006/main">
-            <a:r>
-              <a:t>Sources:</a:t>
-            </a:r>
-          </a:p>
-          <a:p xmlns:a="http://schemas.openxmlformats.org/drawingml/2006/main">
-            <a:r>
-              <a:t>Personal account supplied by Manish Kumar for this review.</a:t>
-            </a:r>
-          </a:p>
         </p:txBody>
       </p:sp>
       <p:sp>
@@ -547,26 +532,6 @@
               <a:t>The intent was to make the frontend understandable and maintainable as feature coverage grew. Pages focus on UI, composables coordinate workflows, stores manage state, API modules isolate HTTP calls, and adapters normalize backend responses. The supplied review lists 40 shared UI components, 49 feature API modules and 36 response adapters. These are project-wide scope indicators. I am not claiming a measured performance improvement or a time-saving percentage.</a:t>
             </a:r>
           </a:p>
-          <a:p xmlns:a="http://schemas.openxmlformats.org/drawingml/2006/main">
-            <a:r>
-              <a:t/>
-            </a:r>
-          </a:p>
-          <a:p xmlns:a="http://schemas.openxmlformats.org/drawingml/2006/main">
-            <a:r>
-              <a:t>Sources:</a:t>
-            </a:r>
-          </a:p>
-          <a:p xmlns:a="http://schemas.openxmlformats.org/drawingml/2006/main">
-            <a:r>
-              <a:t>Personal account supplied by Manish Kumar for this review.</a:t>
-            </a:r>
-          </a:p>
-          <a:p xmlns:a="http://schemas.openxmlformats.org/drawingml/2006/main">
-            <a:r>
-              <a:t>Pasted text (2)(4).txt — ITMS / BMS repository review supplied by Manish Kumar.</a:t>
-            </a:r>
-          </a:p>
         </p:txBody>
       </p:sp>
       <p:sp>
@@ -634,27 +599,7 @@
           <a:lstStyle xmlns:a="http://schemas.openxmlformats.org/drawingml/2006/main"/>
           <a:p xmlns:a="http://schemas.openxmlformats.org/drawingml/2006/main">
             <a:r>
-              <a:t>VLTD was an existing project that I took over. I reviewed four to five portals, created requirements documentation, and documented frontend feature needs. I then improved the existing architecture while continuing feature development. At the same time, I helped new developers understand the workflows and resolved technical doubts. I am describing my stated responsibilities rather than attributing every platform feature to myself.</a:t>
-            </a:r>
-          </a:p>
-          <a:p xmlns:a="http://schemas.openxmlformats.org/drawingml/2006/main">
-            <a:r>
-              <a:t/>
-            </a:r>
-          </a:p>
-          <a:p xmlns:a="http://schemas.openxmlformats.org/drawingml/2006/main">
-            <a:r>
-              <a:t>Sources:</a:t>
-            </a:r>
-          </a:p>
-          <a:p xmlns:a="http://schemas.openxmlformats.org/drawingml/2006/main">
-            <a:r>
-              <a:t>Personal account supplied by Manish Kumar for this review.</a:t>
-            </a:r>
-          </a:p>
-          <a:p xmlns:a="http://schemas.openxmlformats.org/drawingml/2006/main">
-            <a:r>
-              <a:t>Pasted text (3)(2).txt — VLTD repository review supplied by Manish Kumar. Snapshot through 9 September 2026.</a:t>
+              <a:t>VLTD began as a fresh project built by recently joined developers. I lead the frontend work within a six-person team while remaining hands-on with the Transport Department, Fleet Owner, School Management, Driver and project-wide challan workflows. I migrated the entire frontend codebase to another tech stack and improved its architecture for maintainability and scalability. I also plan features, coordinate page updates, mentor junior developers and resolve issues. Other teammates delivered the OEM, FC and RTO panels, including their device workflows.</a:t>
             </a:r>
           </a:p>
         </p:txBody>
@@ -724,27 +669,7 @@
           <a:lstStyle xmlns:a="http://schemas.openxmlformats.org/drawingml/2006/main"/>
           <a:p xmlns:a="http://schemas.openxmlformats.org/drawingml/2006/main">
             <a:r>
-              <a:t>The platform’s broad scope provides context for the architecture and workflow complexity. The repository review covers installation, health and panic checks, repairs, replacement, tracking, emergency alerts, command centres and compliance reports. These are team-level capabilities. My personal account establishes my role in research, architecture migration, complex feature implementation and ongoing RBAC work. Some portals, dashboards and integrations are still evolving.</a:t>
-            </a:r>
-          </a:p>
-          <a:p xmlns:a="http://schemas.openxmlformats.org/drawingml/2006/main">
-            <a:r>
-              <a:t/>
-            </a:r>
-          </a:p>
-          <a:p xmlns:a="http://schemas.openxmlformats.org/drawingml/2006/main">
-            <a:r>
-              <a:t>Sources:</a:t>
-            </a:r>
-          </a:p>
-          <a:p xmlns:a="http://schemas.openxmlformats.org/drawingml/2006/main">
-            <a:r>
-              <a:t>Pasted text (3)(2).txt — VLTD repository review supplied by Manish Kumar. Snapshot through 9 September 2026.</a:t>
-            </a:r>
-          </a:p>
-          <a:p xmlns:a="http://schemas.openxmlformats.org/drawingml/2006/main">
-            <a:r>
-              <a:t>Personal account supplied by Manish Kumar for this review.</a:t>
+              <a:t>My VLTD delivery scope covers the Transport Department, Fleet Owner, School Management and Driver modules, plus the challan workflow across the project. I also improve the architecture across the frontend, with a focus on clean, maintainable and optimized code. I lead the three-person frontend group within the six-person team. Other team members delivered the OEM, FC and RTO panels, including their device workflows, so I do not present that work as my own.</a:t>
             </a:r>
           </a:p>
         </p:txBody>
@@ -817,36 +742,6 @@
               <a:t>Authentication and permissions recur across all three projects. My frontend responsibility includes routes, navigation and permitted actions. The exact implementation differs by project. Backend authorization remains the security boundary, while the frontend gives users a consistent and appropriate experience. I am currently continuing RBAC work in VLTD, so I do not present the whole access-control programme as finished.</a:t>
             </a:r>
           </a:p>
-          <a:p xmlns:a="http://schemas.openxmlformats.org/drawingml/2006/main">
-            <a:r>
-              <a:t/>
-            </a:r>
-          </a:p>
-          <a:p xmlns:a="http://schemas.openxmlformats.org/drawingml/2006/main">
-            <a:r>
-              <a:t>Sources:</a:t>
-            </a:r>
-          </a:p>
-          <a:p xmlns:a="http://schemas.openxmlformats.org/drawingml/2006/main">
-            <a:r>
-              <a:t>Personal account supplied by Manish Kumar for this review.</a:t>
-            </a:r>
-          </a:p>
-          <a:p xmlns:a="http://schemas.openxmlformats.org/drawingml/2006/main">
-            <a:r>
-              <a:t>Pasted text(20260910-154658).txt — RTape repository review supplied by Manish Kumar.</a:t>
-            </a:r>
-          </a:p>
-          <a:p xmlns:a="http://schemas.openxmlformats.org/drawingml/2006/main">
-            <a:r>
-              <a:t>Pasted text (2)(4).txt — ITMS / BMS repository review supplied by Manish Kumar.</a:t>
-            </a:r>
-          </a:p>
-          <a:p xmlns:a="http://schemas.openxmlformats.org/drawingml/2006/main">
-            <a:r>
-              <a:t>Pasted text (3)(2).txt — VLTD repository review supplied by Manish Kumar. Snapshot through 9 September 2026.</a:t>
-            </a:r>
-          </a:p>
         </p:txBody>
       </p:sp>
       <p:sp>
@@ -914,22 +809,7 @@
           <a:lstStyle xmlns:a="http://schemas.openxmlformats.org/drawingml/2006/main"/>
           <a:p xmlns:a="http://schemas.openxmlformats.org/drawingml/2006/main">
             <a:r>
-              <a:t>Alongside implementation, I participated in hiring interviews for senior and intern frontend roles. I guided new developers, mentored an intern and helped junior members resolve technical and workflow questions. I also contributed frontend requirements documentation and coordination with backend teammates. These are examples of increased responsibility, without implying a formal management title or claiming an unmeasured productivity gain.</a:t>
-            </a:r>
-          </a:p>
-          <a:p xmlns:a="http://schemas.openxmlformats.org/drawingml/2006/main">
-            <a:r>
-              <a:t/>
-            </a:r>
-          </a:p>
-          <a:p xmlns:a="http://schemas.openxmlformats.org/drawingml/2006/main">
-            <a:r>
-              <a:t>Sources:</a:t>
-            </a:r>
-          </a:p>
-          <a:p xmlns:a="http://schemas.openxmlformats.org/drawingml/2006/main">
-            <a:r>
-              <a:t>Personal account supplied by Manish Kumar for this review.</a:t>
+              <a:t>Alongside implementation, I lead the three-person frontend group on VLTD within a six-person project team. I plan frontend features and workflows, discuss page updates with frontend and backend teammates, mentor junior developers and help resolve technical and workflow issues. I also participated in hiring interviews for senior and intern frontend roles. These responsibilities show practical leadership without implying a formal management title or claiming an unmeasured productivity gain.</a:t>
             </a:r>
           </a:p>
         </p:txBody>
@@ -999,37 +879,7 @@
           <a:lstStyle xmlns:a="http://schemas.openxmlformats.org/drawingml/2006/main"/>
           <a:p xmlns:a="http://schemas.openxmlformats.org/drawingml/2006/main">
             <a:r>
-              <a:t>For Atlanta, my contribution has been the ability to take frontend work from ambiguous requirements through implementation and stakeholder review. RTape provides the clearest reported business milestone in the tender win. ITMS enabled broad operational coverage using shared architecture. On VLTD, I have helped improve the structure and supported team delivery. Production adoption, revenue and time-saving metrics were not supplied, so I have not invented them.</a:t>
-            </a:r>
-          </a:p>
-          <a:p xmlns:a="http://schemas.openxmlformats.org/drawingml/2006/main">
-            <a:r>
-              <a:t/>
-            </a:r>
-          </a:p>
-          <a:p xmlns:a="http://schemas.openxmlformats.org/drawingml/2006/main">
-            <a:r>
-              <a:t>Sources:</a:t>
-            </a:r>
-          </a:p>
-          <a:p xmlns:a="http://schemas.openxmlformats.org/drawingml/2006/main">
-            <a:r>
-              <a:t>Personal account supplied by Manish Kumar for this review.</a:t>
-            </a:r>
-          </a:p>
-          <a:p xmlns:a="http://schemas.openxmlformats.org/drawingml/2006/main">
-            <a:r>
-              <a:t>Pasted text(20260910-154658).txt — RTape repository review supplied by Manish Kumar.</a:t>
-            </a:r>
-          </a:p>
-          <a:p xmlns:a="http://schemas.openxmlformats.org/drawingml/2006/main">
-            <a:r>
-              <a:t>Pasted text (2)(4).txt — ITMS / BMS repository review supplied by Manish Kumar.</a:t>
-            </a:r>
-          </a:p>
-          <a:p xmlns:a="http://schemas.openxmlformats.org/drawingml/2006/main">
-            <a:r>
-              <a:t>Pasted text (3)(2).txt — VLTD repository review supplied by Manish Kumar. Snapshot through 9 September 2026.</a:t>
+              <a:t>For Atlanta, my contribution has been the ability to take frontend work from ambiguous requirements through implementation and stakeholder review. RTape provides the clearest reported business milestone in its selection for state-level deployment in Madhya Pradesh. On ITMS, I solely built the complete frontend from scratch. On VLTD, I lead the frontend work, own major modules and completed the full frontend codebase migration to a new tech stack. Production adoption, revenue and time-saving metrics were not supplied, so I have not invented them.</a:t>
             </a:r>
           </a:p>
         </p:txBody>
@@ -1099,37 +949,7 @@
           <a:lstStyle xmlns:a="http://schemas.openxmlformats.org/drawingml/2006/main"/>
           <a:p xmlns:a="http://schemas.openxmlformats.org/drawingml/2006/main">
             <a:r>
-              <a:t>These are proposed priorities, not completed achievements. The supplied reviews show opportunities in integration completeness, automated testing, architecture cleanup and production measurement. I would like to take broader ownership of those areas and continue helping other developers. The specific sequence should align with business priorities and backend readiness.</a:t>
-            </a:r>
-          </a:p>
-          <a:p xmlns:a="http://schemas.openxmlformats.org/drawingml/2006/main">
-            <a:r>
-              <a:t/>
-            </a:r>
-          </a:p>
-          <a:p xmlns:a="http://schemas.openxmlformats.org/drawingml/2006/main">
-            <a:r>
-              <a:t>Sources:</a:t>
-            </a:r>
-          </a:p>
-          <a:p xmlns:a="http://schemas.openxmlformats.org/drawingml/2006/main">
-            <a:r>
-              <a:t>Personal account supplied by Manish Kumar for this review.</a:t>
-            </a:r>
-          </a:p>
-          <a:p xmlns:a="http://schemas.openxmlformats.org/drawingml/2006/main">
-            <a:r>
-              <a:t>Pasted text(20260910-154658).txt — RTape repository review supplied by Manish Kumar.</a:t>
-            </a:r>
-          </a:p>
-          <a:p xmlns:a="http://schemas.openxmlformats.org/drawingml/2006/main">
-            <a:r>
-              <a:t>Pasted text (2)(4).txt — ITMS / BMS repository review supplied by Manish Kumar.</a:t>
-            </a:r>
-          </a:p>
-          <a:p xmlns:a="http://schemas.openxmlformats.org/drawingml/2006/main">
-            <a:r>
-              <a:t>Pasted text (3)(2).txt — VLTD repository review supplied by Manish Kumar. Snapshot through 9 September 2026.</a:t>
+              <a:t>I am already familiar with backend concepts and am improving my practical backend skills through implementation and integration work. I am also learning server-side setup, deployment and troubleshooting so I can support the complete project workflow. As these skills grow, I want to take greater ownership from requirements through delivery and support, increasing the work I can handle for Atlanta. I will adapt to new requirements and learn technologies that upcoming projects need. These are future growth goals, not completed achievements or fixed-date commitments.</a:t>
             </a:r>
           </a:p>
         </p:txBody>
@@ -1202,31 +1022,6 @@
               <a:t>This reference slide provides a sense of project scope. The counts come from the three supplied reviews and are not normalized or freshly audited. RTape and ITMS count Vue components or pages, while VLTD counts Vue files. They should not be added together or used to compare developer productivity. ITMS personal commit attribution depends on confirmation of two Git identities, so that conditional figure is not used as a personal headline. VLTD counts are explicitly project-wide.</a:t>
             </a:r>
           </a:p>
-          <a:p xmlns:a="http://schemas.openxmlformats.org/drawingml/2006/main">
-            <a:r>
-              <a:t/>
-            </a:r>
-          </a:p>
-          <a:p xmlns:a="http://schemas.openxmlformats.org/drawingml/2006/main">
-            <a:r>
-              <a:t>Sources:</a:t>
-            </a:r>
-          </a:p>
-          <a:p xmlns:a="http://schemas.openxmlformats.org/drawingml/2006/main">
-            <a:r>
-              <a:t>Pasted text(20260910-154658).txt — RTape repository review supplied by Manish Kumar.</a:t>
-            </a:r>
-          </a:p>
-          <a:p xmlns:a="http://schemas.openxmlformats.org/drawingml/2006/main">
-            <a:r>
-              <a:t>Pasted text (2)(4).txt — ITMS / BMS repository review supplied by Manish Kumar.</a:t>
-            </a:r>
-          </a:p>
-          <a:p xmlns:a="http://schemas.openxmlformats.org/drawingml/2006/main">
-            <a:r>
-              <a:t>Pasted text (3)(2).txt — VLTD repository review supplied by Manish Kumar. Snapshot through 9 September 2026.</a:t>
-            </a:r>
-          </a:p>
         </p:txBody>
       </p:sp>
       <p:sp>
@@ -1297,21 +1092,6 @@
               <a:t>Thank you for the opportunities and trust during this period. These projects have helped me grow from a junior developer into someone who can own frontend delivery, make architecture decisions and support teammates. I welcome feedback on my contribution and the responsibilities I should take on next.</a:t>
             </a:r>
           </a:p>
-          <a:p xmlns:a="http://schemas.openxmlformats.org/drawingml/2006/main">
-            <a:r>
-              <a:t/>
-            </a:r>
-          </a:p>
-          <a:p xmlns:a="http://schemas.openxmlformats.org/drawingml/2006/main">
-            <a:r>
-              <a:t>Sources:</a:t>
-            </a:r>
-          </a:p>
-          <a:p xmlns:a="http://schemas.openxmlformats.org/drawingml/2006/main">
-            <a:r>
-              <a:t>Personal account supplied by Manish Kumar for this review.</a:t>
-            </a:r>
-          </a:p>
         </p:txBody>
       </p:sp>
       <p:sp>
@@ -1379,22 +1159,7 @@
           <a:lstStyle xmlns:a="http://schemas.openxmlformats.org/drawingml/2006/main"/>
           <a:p xmlns:a="http://schemas.openxmlformats.org/drawingml/2006/main">
             <a:r>
-              <a:t>My strongest contribution was taking responsibility for frontend delivery in small teams. On RTape and ITMS, the team consisted of two members. For VLTD, I researched four to five existing portals before helping define requirements. The tender win belongs to the project team. My contribution covered frontend delivery, live testing, demonstrations and follow-up support.</a:t>
-            </a:r>
-          </a:p>
-          <a:p xmlns:a="http://schemas.openxmlformats.org/drawingml/2006/main">
-            <a:r>
-              <a:t/>
-            </a:r>
-          </a:p>
-          <a:p xmlns:a="http://schemas.openxmlformats.org/drawingml/2006/main">
-            <a:r>
-              <a:t>Sources:</a:t>
-            </a:r>
-          </a:p>
-          <a:p xmlns:a="http://schemas.openxmlformats.org/drawingml/2006/main">
-            <a:r>
-              <a:t>Personal account supplied by Manish Kumar for this review.</a:t>
+              <a:t>My strongest contribution was taking responsibility for frontend delivery. I solely built the ITMS frontend from scratch. On VLTD, I lead the frontend work within a six-person team of three frontend and three backend developers. I also researched four to five existing portals before helping define requirements. RTape’s selection for state-level deployment in Madhya Pradesh belongs to the project team. My contribution covered frontend delivery, live testing, demonstrations and follow-up support.</a:t>
             </a:r>
           </a:p>
         </p:txBody>
@@ -1464,22 +1229,7 @@
           <a:lstStyle xmlns:a="http://schemas.openxmlformats.org/drawingml/2006/main"/>
           <a:p xmlns:a="http://schemas.openxmlformats.org/drawingml/2006/main">
             <a:r>
-              <a:t>These projects describe a progression in responsibility, rather than a formal change in job title. RTape developed my ownership of delivery. ITMS gave me greater responsibility for architecture and system design. On VLTD, I combined feature work with requirements, architecture migration, interviews and guidance for other developers. Work on these projects overlapped.</a:t>
-            </a:r>
-          </a:p>
-          <a:p xmlns:a="http://schemas.openxmlformats.org/drawingml/2006/main">
-            <a:r>
-              <a:t/>
-            </a:r>
-          </a:p>
-          <a:p xmlns:a="http://schemas.openxmlformats.org/drawingml/2006/main">
-            <a:r>
-              <a:t>Sources:</a:t>
-            </a:r>
-          </a:p>
-          <a:p xmlns:a="http://schemas.openxmlformats.org/drawingml/2006/main">
-            <a:r>
-              <a:t>Personal account supplied by Manish Kumar for this review.</a:t>
+              <a:t>These projects describe a progression in responsibility, rather than a formal change in job title. RTape developed my ownership of delivery. On ITMS, I solely built the complete frontend from scratch, including its architecture and operational workflows. On VLTD, I lead the frontend work, own major modules, plan features and workflows, coordinate page updates with the full team, mentor junior developers and help resolve issues. Work on these projects overlapped.</a:t>
             </a:r>
           </a:p>
         </p:txBody>
@@ -1549,27 +1299,7 @@
           <a:lstStyle xmlns:a="http://schemas.openxmlformats.org/drawingml/2006/main"/>
           <a:p xmlns:a="http://schemas.openxmlformats.org/drawingml/2006/main">
             <a:r>
-              <a:t>RTape was my first major project at Atlanta. The system connects manufacturers, fitment centres, transport authorities, inspectors and citizens. I took ownership of the frontend, with initial direction from Ritesh sir and close coordination with my backend teammate. Limited documentation meant I often had to research workflows, clarify requirements and solve technical problems independently, including additional study outside office hours.</a:t>
-            </a:r>
-          </a:p>
-          <a:p xmlns:a="http://schemas.openxmlformats.org/drawingml/2006/main">
-            <a:r>
-              <a:t/>
-            </a:r>
-          </a:p>
-          <a:p xmlns:a="http://schemas.openxmlformats.org/drawingml/2006/main">
-            <a:r>
-              <a:t>Sources:</a:t>
-            </a:r>
-          </a:p>
-          <a:p xmlns:a="http://schemas.openxmlformats.org/drawingml/2006/main">
-            <a:r>
-              <a:t>Personal account supplied by Manish Kumar for this review.</a:t>
-            </a:r>
-          </a:p>
-          <a:p xmlns:a="http://schemas.openxmlformats.org/drawingml/2006/main">
-            <a:r>
-              <a:t>Pasted text(20260910-154658).txt — RTape repository review supplied by Manish Kumar.</a:t>
+              <a:t>RTape was my first major project at Atlanta. The system connects manufacturers, fitment centres, transport authorities, inspectors and citizens. I took ownership of the frontend, with initial direction from the team lead and close coordination with my backend teammate. Limited documentation meant I often had to research workflows, clarify requirements and solve technical problems independently, including additional study outside office hours.</a:t>
             </a:r>
           </a:p>
         </p:txBody>
@@ -1642,26 +1372,6 @@
               <a:t>The supplied RTape review attributes work to me in authentication, complaints, appointments, certificates, localization, inventory workflows and responsive UI. Examples include appointment booking with OTP, complaint lifecycle tracking, inventory discard, OEM price-change approvals, vehicle-fitment verification and public PDF certificates. These capabilities helped make the platform usable for both operational users and citizens.</a:t>
             </a:r>
           </a:p>
-          <a:p xmlns:a="http://schemas.openxmlformats.org/drawingml/2006/main">
-            <a:r>
-              <a:t/>
-            </a:r>
-          </a:p>
-          <a:p xmlns:a="http://schemas.openxmlformats.org/drawingml/2006/main">
-            <a:r>
-              <a:t>Sources:</a:t>
-            </a:r>
-          </a:p>
-          <a:p xmlns:a="http://schemas.openxmlformats.org/drawingml/2006/main">
-            <a:r>
-              <a:t>Pasted text(20260910-154658).txt — RTape repository review supplied by Manish Kumar.</a:t>
-            </a:r>
-          </a:p>
-          <a:p xmlns:a="http://schemas.openxmlformats.org/drawingml/2006/main">
-            <a:r>
-              <a:t>Personal account supplied by Manish Kumar for this review.</a:t>
-            </a:r>
-          </a:p>
         </p:txBody>
       </p:sp>
       <p:sp>
@@ -1729,22 +1439,7 @@
           <a:lstStyle xmlns:a="http://schemas.openxmlformats.org/drawingml/2006/main"/>
           <a:p xmlns:a="http://schemas.openxmlformats.org/drawingml/2006/main">
             <a:r>
-              <a:t>My responsibilities extended beyond implementation. I helped prepare and test the full workflow, participated in demo meetings, presented at the Noida office named BESIL in my account, and supported Ritesh sir during the Madhya Pradesh demonstration. The project successfully won the government tender. I describe that as a team achievement and identify my own support clearly. I also helped with documentation and subsequent updates.</a:t>
-            </a:r>
-          </a:p>
-          <a:p xmlns:a="http://schemas.openxmlformats.org/drawingml/2006/main">
-            <a:r>
-              <a:t/>
-            </a:r>
-          </a:p>
-          <a:p xmlns:a="http://schemas.openxmlformats.org/drawingml/2006/main">
-            <a:r>
-              <a:t>Sources:</a:t>
-            </a:r>
-          </a:p>
-          <a:p xmlns:a="http://schemas.openxmlformats.org/drawingml/2006/main">
-            <a:r>
-              <a:t>Personal account supplied by Manish Kumar for this review.</a:t>
+              <a:t>My responsibilities extended beyond implementation. I helped prepare and test the full workflow, participated in demo meetings, presented at the Noida office named BESIL in my account, and supported the team lead during the Madhya Pradesh demonstration. The project was selected for state-level deployment in Madhya Pradesh. I describe that as a team achievement and identify my own support clearly. I also helped with documentation and subsequent updates.</a:t>
             </a:r>
           </a:p>
         </p:txBody>
@@ -1814,22 +1509,7 @@
           <a:lstStyle xmlns:a="http://schemas.openxmlformats.org/drawingml/2006/main"/>
           <a:p xmlns:a="http://schemas.openxmlformats.org/drawingml/2006/main">
             <a:r>
-              <a:t>These are figures from the supplied repository review, not a fresh audit. The review attributes 280 branch-lifetime commits to Manish Kumar, including 89 during 2026, and changes to 168 unique files in 2026. The 64% share applies only to the project’s 2026 commit activity. It does not describe ownership percentage or business value. I use delivered workflows and the tender milestone to explain the impact alongside this evidence.</a:t>
-            </a:r>
-          </a:p>
-          <a:p xmlns:a="http://schemas.openxmlformats.org/drawingml/2006/main">
-            <a:r>
-              <a:t/>
-            </a:r>
-          </a:p>
-          <a:p xmlns:a="http://schemas.openxmlformats.org/drawingml/2006/main">
-            <a:r>
-              <a:t>Sources:</a:t>
-            </a:r>
-          </a:p>
-          <a:p xmlns:a="http://schemas.openxmlformats.org/drawingml/2006/main">
-            <a:r>
-              <a:t>Pasted text(20260910-154658).txt — RTape repository review supplied by Manish Kumar.</a:t>
+              <a:t>These are figures from the supplied repository review, not a fresh audit. The review attributes 280 branch-lifetime commits to Manish Kumar, including 89 during 2026, and changes to 168 unique files in 2026. The 64% share applies only to the project’s 2026 commit activity. It does not describe ownership percentage or business value. I use delivered workflows and the state-level selection milestone to explain the impact alongside this evidence.</a:t>
             </a:r>
           </a:p>
         </p:txBody>
@@ -1899,27 +1579,7 @@
           <a:lstStyle xmlns:a="http://schemas.openxmlformats.org/drawingml/2006/main"/>
           <a:p xmlns:a="http://schemas.openxmlformats.org/drawingml/2006/main">
             <a:r>
-              <a:t>ITMS broadened my work into frontend system design. With one other team member, I researched requirements, planned the functional and non-functional scope, designed the frontend architecture and worked on features end to end. The platform serves state administration, depot managers and staff, drivers, conductors and passengers. Complex workflows required continuous R&amp;D and coordination with evolving backend APIs.</a:t>
-            </a:r>
-          </a:p>
-          <a:p xmlns:a="http://schemas.openxmlformats.org/drawingml/2006/main">
-            <a:r>
-              <a:t/>
-            </a:r>
-          </a:p>
-          <a:p xmlns:a="http://schemas.openxmlformats.org/drawingml/2006/main">
-            <a:r>
-              <a:t>Sources:</a:t>
-            </a:r>
-          </a:p>
-          <a:p xmlns:a="http://schemas.openxmlformats.org/drawingml/2006/main">
-            <a:r>
-              <a:t>Personal account supplied by Manish Kumar for this review.</a:t>
-            </a:r>
-          </a:p>
-          <a:p xmlns:a="http://schemas.openxmlformats.org/drawingml/2006/main">
-            <a:r>
-              <a:t>Pasted text (2)(4).txt — ITMS / BMS repository review supplied by Manish Kumar.</a:t>
+              <a:t>ITMS broadened my work into full frontend ownership. I solely built the complete frontend from scratch, including requirements research, functional and non-functional planning, architecture and end-to-end feature delivery. The platform serves state administration, depot managers and staff, drivers, conductors and passengers. Complex workflows required continuous R&amp;D and coordination with evolving backend APIs.</a:t>
             </a:r>
           </a:p>
         </p:txBody>
@@ -1990,26 +1650,6 @@
           <a:p xmlns:a="http://schemas.openxmlformats.org/drawingml/2006/main">
             <a:r>
               <a:t>The ITMS scope spans workforce and fleet management, depot resources, shift execution, tracking, incident handling and reporting. The ten-report depot area includes missed shifts, login activity, assignment history, vehicle audit, device health and other operational reports. Driver and conductor portals support field workflows, while the Passenger Information System exposes supported bus, route, stop and trip information. This describes implemented scope, not a claim that every module has completed production hardening.</a:t>
-            </a:r>
-          </a:p>
-          <a:p xmlns:a="http://schemas.openxmlformats.org/drawingml/2006/main">
-            <a:r>
-              <a:t/>
-            </a:r>
-          </a:p>
-          <a:p xmlns:a="http://schemas.openxmlformats.org/drawingml/2006/main">
-            <a:r>
-              <a:t>Sources:</a:t>
-            </a:r>
-          </a:p>
-          <a:p xmlns:a="http://schemas.openxmlformats.org/drawingml/2006/main">
-            <a:r>
-              <a:t>Personal account supplied by Manish Kumar for this review.</a:t>
-            </a:r>
-          </a:p>
-          <a:p xmlns:a="http://schemas.openxmlformats.org/drawingml/2006/main">
-            <a:r>
-              <a:t>Pasted text (2)(4).txt — ITMS / BMS repository review supplied by Manish Kumar.</a:t>
             </a:r>
           </a:p>
         </p:txBody>
@@ -2077,7 +1717,7 @@
   </p:cSld>
   <p:clrMap bg1="lt1" tx1="dk1" bg2="lt2" tx2="dk2" accent1="accent1" accent2="accent2" accent3="accent3" accent4="accent4" accent5="accent5" accent6="accent6" hlink="hlink" folHlink="folHlink"/>
   <p:sldLayoutIdLst>
-    <p:sldLayoutId xmlns:r="http://schemas.openxmlformats.org/officeDocument/2006/relationships" id="2147483649" r:id="R5dbc15e422714df5"/>
+    <p:sldLayoutId xmlns:r="http://schemas.openxmlformats.org/officeDocument/2006/relationships" id="2147483649" r:id="R503e2208c5c5451a"/>
   </p:sldLayoutIdLst>
   <p:txStyles>
     <p:titleStyle>
@@ -4992,7 +4632,7 @@
                 <a:ea typeface="Arial"/>
                 <a:cs typeface="Arial"/>
               </a:rPr>
-              <a:t>Taking over</a:t>
+              <a:t>Migrated the VLTD frontend</a:t>
             </a:r>
           </a:p>
           <a:p xmlns:a="http://schemas.openxmlformats.org/drawingml/2006/main">
@@ -5019,7 +4659,7 @@
                 <a:ea typeface="Arial"/>
                 <a:cs typeface="Arial"/>
               </a:rPr>
-              <a:t>an evolving platform</a:t>
+              <a:t>for maintainability and scale</a:t>
             </a:r>
           </a:p>
         </p:txBody>
@@ -5080,7 +4720,7 @@
                 <a:ea typeface="Arial"/>
                 <a:cs typeface="Arial"/>
               </a:rPr>
-              <a:t>Vehicle tracking, device lifecycle management and transport compliance</a:t>
+              <a:t>A new vehicle tracking and compliance platform started by recently joined developers</a:t>
             </a:r>
           </a:p>
         </p:txBody>
@@ -5141,7 +4781,7 @@
                 <a:ea typeface="Arial"/>
                 <a:cs typeface="Arial"/>
               </a:rPr>
-              <a:t>I combined architecture improvements with feature delivery and team guidance.</a:t>
+              <a:t>I moved the entire frontend codebase to a new tech stack.</a:t>
             </a:r>
           </a:p>
         </p:txBody>
@@ -5232,7 +4872,7 @@
                 <a:ea typeface="Arial"/>
                 <a:cs typeface="Arial"/>
               </a:rPr>
-              <a:t>Research before implementation</a:t>
+              <a:t>Modules and workflows</a:t>
             </a:r>
           </a:p>
         </p:txBody>
@@ -5293,7 +4933,7 @@
                 <a:ea typeface="Arial"/>
                 <a:cs typeface="Arial"/>
               </a:rPr>
-              <a:t>Reviewed 4–5 portals and documented functional and non-functional requirements.</a:t>
+              <a:t>Transport Department, Fleet Owner, School Management, Driver and challan workflows.</a:t>
             </a:r>
           </a:p>
         </p:txBody>
@@ -5354,7 +4994,7 @@
                 <a:ea typeface="Arial"/>
                 <a:cs typeface="Arial"/>
               </a:rPr>
-              <a:t>A clearer architecture</a:t>
+              <a:t>Migration and architecture</a:t>
             </a:r>
           </a:p>
         </p:txBody>
@@ -5415,7 +5055,7 @@
                 <a:ea typeface="Arial"/>
                 <a:cs typeface="Arial"/>
               </a:rPr>
-              <a:t>Migrated the existing structure to make the code easier to understand and maintain.</a:t>
+              <a:t>Reworked the architecture to make the codebase easier to maintain and scale.</a:t>
             </a:r>
           </a:p>
         </p:txBody>
@@ -5476,7 +5116,7 @@
                 <a:ea typeface="Arial"/>
                 <a:cs typeface="Arial"/>
               </a:rPr>
-              <a:t>Continued delivery</a:t>
+              <a:t>Frontend leadership</a:t>
             </a:r>
           </a:p>
         </p:txBody>
@@ -5537,7 +5177,7 @@
                 <a:ea typeface="Arial"/>
                 <a:cs typeface="Arial"/>
               </a:rPr>
-              <a:t>Worked on complex flows while resolving questions from junior developers.</a:t>
+              <a:t>Plan features, align page updates, mentor juniors and resolve implementation issues.</a:t>
             </a:r>
           </a:p>
         </p:txBody>
@@ -5627,7 +5267,7 @@
                 <a:ea typeface="Arial"/>
                 <a:cs typeface="Arial"/>
               </a:rPr>
-              <a:t>VLTD / PLATFORM SCOPE</a:t>
+              <a:t>VLTD / MY DELIVERY SCOPE</a:t>
             </a:r>
           </a:p>
         </p:txBody>
@@ -5749,7 +5389,7 @@
                 <a:ea typeface="Arial"/>
                 <a:cs typeface="Arial"/>
               </a:rPr>
-              <a:t>Capabilities describe the team’s platform. My ownership is stated separately.</a:t>
+              <a:t>OEM, FC and RTO panels, including device workflows, were delivered by other team members.</a:t>
             </a:r>
           </a:p>
         </p:txBody>
@@ -5871,7 +5511,7 @@
                 <a:ea typeface="Arial"/>
                 <a:cs typeface="Arial"/>
               </a:rPr>
-              <a:t>Complex workflows across the device lifecycle</a:t>
+              <a:t>My frontend ownership within VLTD</a:t>
             </a:r>
           </a:p>
         </p:txBody>
@@ -6023,7 +5663,7 @@
                 <a:ea typeface="Arial"/>
                 <a:cs typeface="Arial"/>
               </a:rPr>
-              <a:t>Install and verify</a:t>
+              <a:t>Transport Department</a:t>
             </a:r>
           </a:p>
         </p:txBody>
@@ -6084,7 +5724,7 @@
                 <a:ea typeface="Arial"/>
                 <a:cs typeface="Arial"/>
               </a:rPr>
-              <a:t>Vehicle validation, device selection, health checks, panic tests and evidence uploads.</a:t>
+              <a:t>Operational workflows for transport department users.</a:t>
             </a:r>
           </a:p>
         </p:txBody>
@@ -6236,7 +5876,7 @@
                 <a:ea typeface="Arial"/>
                 <a:cs typeface="Arial"/>
               </a:rPr>
-              <a:t>Maintain and replace</a:t>
+              <a:t>Fleet, school and driver</a:t>
             </a:r>
           </a:p>
         </p:txBody>
@@ -6297,7 +5937,7 @@
                 <a:ea typeface="Arial"/>
                 <a:cs typeface="Arial"/>
               </a:rPr>
-              <a:t>Repair workflows, replacement, status history and QR-enabled PDF receipts.</a:t>
+              <a:t>Frontend modules for fleet owners, school management and drivers.</a:t>
             </a:r>
           </a:p>
         </p:txBody>
@@ -6449,7 +6089,7 @@
                 <a:ea typeface="Arial"/>
                 <a:cs typeface="Arial"/>
               </a:rPr>
-              <a:t>Monitor and govern</a:t>
+              <a:t>Challan workflow</a:t>
             </a:r>
           </a:p>
         </p:txBody>
@@ -6510,7 +6150,7 @@
                 <a:ea typeface="Arial"/>
                 <a:cs typeface="Arial"/>
               </a:rPr>
-              <a:t>Tracking, alerts, command centres, challans and operational reports.</a:t>
+              <a:t>Plan and implement the challan flow across the project.</a:t>
             </a:r>
           </a:p>
         </p:txBody>
@@ -6662,7 +6302,7 @@
                 <a:ea typeface="Arial"/>
                 <a:cs typeface="Arial"/>
               </a:rPr>
-              <a:t>Extend role access</a:t>
+              <a:t>Architecture and quality</a:t>
             </a:r>
           </a:p>
         </p:txBody>
@@ -6723,7 +6363,7 @@
                 <a:ea typeface="Arial"/>
                 <a:cs typeface="Arial"/>
               </a:rPr>
-              <a:t>Dedicated portals for authorities, OEMs, fitment centres, inspectors and fleet owners.</a:t>
+              <a:t>Improve the whole frontend with clean, maintainable and optimized code.</a:t>
             </a:r>
           </a:p>
         </p:txBody>
@@ -6844,7 +6484,7 @@
                 <a:ea typeface="Arial"/>
                 <a:cs typeface="Arial"/>
               </a:rPr>
-              <a:t>My current focus includes RBAC, complex feature work and maintainable shared patterns.</a:t>
+              <a:t>I combine module ownership with frontend leadership across the six-person team.</a:t>
             </a:r>
           </a:p>
         </p:txBody>
@@ -8576,7 +8216,7 @@
                 <a:ea typeface="Arial"/>
                 <a:cs typeface="Arial"/>
               </a:rPr>
-              <a:t>Supporting delivery through people</a:t>
+              <a:t>Frontend leadership and team support</a:t>
             </a:r>
           </a:p>
         </p:txBody>
@@ -8941,7 +8581,7 @@
                 <a:ea typeface="Arial"/>
                 <a:cs typeface="Arial"/>
               </a:rPr>
-              <a:t>Developer onboarding</a:t>
+              <a:t>VLTD frontend leadership</a:t>
             </a:r>
           </a:p>
         </p:txBody>
@@ -9002,7 +8642,7 @@
                 <a:ea typeface="Arial"/>
                 <a:cs typeface="Arial"/>
               </a:rPr>
-              <a:t>Guided new developers through project structure and business workflows.</a:t>
+              <a:t>Lead three frontend developers across feature planning, workflows and delivery.</a:t>
             </a:r>
           </a:p>
         </p:txBody>
@@ -9154,7 +8794,7 @@
                 <a:ea typeface="Arial"/>
                 <a:cs typeface="Arial"/>
               </a:rPr>
-              <a:t>Mentoring</a:t>
+              <a:t>Mentoring and issue resolution</a:t>
             </a:r>
           </a:p>
         </p:txBody>
@@ -9215,7 +8855,7 @@
                 <a:ea typeface="Arial"/>
                 <a:cs typeface="Arial"/>
               </a:rPr>
-              <a:t>Helped an intern and junior members with technical questions and implementation.</a:t>
+              <a:t>Help junior developers with technical questions, implementation and blockers.</a:t>
             </a:r>
           </a:p>
         </p:txBody>
@@ -9367,7 +9007,7 @@
                 <a:ea typeface="Arial"/>
                 <a:cs typeface="Arial"/>
               </a:rPr>
-              <a:t>Shared understanding</a:t>
+              <a:t>Team alignment</a:t>
             </a:r>
           </a:p>
         </p:txBody>
@@ -9428,7 +9068,7 @@
                 <a:ea typeface="Arial"/>
                 <a:cs typeface="Arial"/>
               </a:rPr>
-              <a:t>Created requirements documentation and coordinated workflows with backend teammates.</a:t>
+              <a:t>Review page updates and workflow decisions with frontend and backend teammates.</a:t>
             </a:r>
           </a:p>
         </p:txBody>
@@ -9549,7 +9189,7 @@
                 <a:ea typeface="Arial"/>
                 <a:cs typeface="Arial"/>
               </a:rPr>
-              <a:t>My responsibilities expanded to helping other developers move their work forward.</a:t>
+              <a:t>My responsibilities now include leading frontend delivery while helping teammates move their work forward.</a:t>
             </a:r>
           </a:p>
         </p:txBody>
@@ -9761,7 +9401,7 @@
                 <a:ea typeface="Arial"/>
                 <a:cs typeface="Arial"/>
               </a:rPr>
-              <a:t>Qualitative value, except the reported tender outcome. No adoption, revenue or time-saving figures are assumed.</a:t>
+              <a:t>Qualitative value, except the reported project selection. No adoption, revenue or time-saving figures are assumed.</a:t>
             </a:r>
           </a:p>
         </p:txBody>
@@ -9890,7 +9530,7 @@
       </p:sp>
       <p:graphicFrame>
         <p:nvGraphicFramePr>
-          <p:cNvPr id="12" name=""/>
+          <p:cNvPr id="14" name=""/>
           <p:cNvGraphicFramePr/>
           <p:nvPr/>
         </p:nvGraphicFramePr>
@@ -10092,7 +9732,7 @@
                           <a:ea typeface="Arial"/>
                           <a:cs typeface="Arial"/>
                         </a:rPr>
-                        <a:t>A working platform for stakeholder demos and a contribution to the team’s tender win</a:t>
+                        <a:t>A working platform selected for state-level deployment in Madhya Pradesh</a:t>
                       </a:r>
                     </a:p>
                   </a:txBody>
@@ -10158,7 +9798,7 @@
                           <a:ea typeface="Arial"/>
                           <a:cs typeface="Arial"/>
                         </a:rPr>
-                        <a:t>Frontend system design and end-to-end operational features</a:t>
+                        <a:t>Sole ownership of the complete frontend, built from scratch</a:t>
                       </a:r>
                     </a:p>
                   </a:txBody>
@@ -10256,7 +9896,7 @@
                           <a:ea typeface="Arial"/>
                           <a:cs typeface="Arial"/>
                         </a:rPr>
-                        <a:t>Requirements, architecture migration, complex flows and mentoring</a:t>
+                        <a:t>Frontend leadership, key modules and full frontend migration</a:t>
                       </a:r>
                     </a:p>
                   </a:txBody>
@@ -10288,7 +9928,7 @@
                           <a:ea typeface="Arial"/>
                           <a:cs typeface="Arial"/>
                         </a:rPr>
-                        <a:t>A clearer structure for continued development across a growing team</a:t>
+                        <a:t>A maintainable frontend foundation for future delivery</a:t>
                       </a:r>
                     </a:p>
                   </a:txBody>
@@ -10388,7 +10028,7 @@
                 <a:ea typeface="Arial"/>
                 <a:cs typeface="Arial"/>
               </a:rPr>
-              <a:t>NEXT PHASE / PROPOSED PRIORITIES</a:t>
+              <a:t>NEXT PHASE / GROWTH ROADMAP</a:t>
             </a:r>
           </a:p>
         </p:txBody>
@@ -10632,7 +10272,7 @@
                 <a:ea typeface="Arial"/>
                 <a:cs typeface="Arial"/>
               </a:rPr>
-              <a:t>Strengthening delivery in the next year</a:t>
+              <a:t>Future growth and contribution plan</a:t>
             </a:r>
           </a:p>
         </p:txBody>
@@ -10784,7 +10424,7 @@
                 <a:ea typeface="Arial"/>
                 <a:cs typeface="Arial"/>
               </a:rPr>
-              <a:t>Complete current workflows</a:t>
+              <a:t>Apply backend knowledge</a:t>
             </a:r>
           </a:p>
         </p:txBody>
@@ -10845,7 +10485,7 @@
                 <a:ea typeface="Arial"/>
                 <a:cs typeface="Arial"/>
               </a:rPr>
-              <a:t>Continue VLTD permissions and close remaining API and dashboard integration gaps.</a:t>
+              <a:t>Take on more backend implementation and integration work to turn existing knowledge into practical delivery.</a:t>
             </a:r>
           </a:p>
         </p:txBody>
@@ -10997,7 +10637,7 @@
                 <a:ea typeface="Arial"/>
                 <a:cs typeface="Arial"/>
               </a:rPr>
-              <a:t>Make quality repeatable</a:t>
+              <a:t>Build server-side skills</a:t>
             </a:r>
           </a:p>
         </p:txBody>
@@ -11058,7 +10698,7 @@
                 <a:ea typeface="Arial"/>
                 <a:cs typeface="Arial"/>
               </a:rPr>
-              <a:t>Add focused tests for auth, permissions and critical installation workflows.</a:t>
+              <a:t>Learn server setup, deployment and troubleshooting so I can support applications beyond the frontend.</a:t>
             </a:r>
           </a:p>
         </p:txBody>
@@ -11210,7 +10850,7 @@
                 <a:ea typeface="Arial"/>
                 <a:cs typeface="Arial"/>
               </a:rPr>
-              <a:t>Improve maintainability</a:t>
+              <a:t>Own complete workflows</a:t>
             </a:r>
           </a:p>
         </p:txBody>
@@ -11271,7 +10911,7 @@
                 <a:ea typeface="Arial"/>
                 <a:cs typeface="Arial"/>
               </a:rPr>
-              <a:t>Continue shared patterns, simplify large pages and document implementation decisions.</a:t>
+              <a:t>Combine frontend, backend and server-side skills to take responsibility from requirements through delivery and support.</a:t>
             </a:r>
           </a:p>
         </p:txBody>
@@ -11423,7 +11063,7 @@
                 <a:ea typeface="Arial"/>
                 <a:cs typeface="Arial"/>
               </a:rPr>
-              <a:t>Measure results</a:t>
+              <a:t>Adapt to new needs</a:t>
             </a:r>
           </a:p>
         </p:txBody>
@@ -11484,7 +11124,7 @@
                 <a:ea typeface="Arial"/>
                 <a:cs typeface="Arial"/>
               </a:rPr>
-              <a:t>Track production usage, reliability and support outcomes with the team.</a:t>
+              <a:t>Learn technologies required by new projects and adapt as company needs change.</a:t>
             </a:r>
           </a:p>
         </p:txBody>
@@ -11605,7 +11245,7 @@
                 <a:ea typeface="Arial"/>
                 <a:cs typeface="Arial"/>
               </a:rPr>
-              <a:t>Take broader frontend ownership while making delivery easier to sustain.</a:t>
+              <a:t>My goal is to take broader project ownership and contribute more across Atlanta’s work.</a:t>
             </a:r>
           </a:p>
         </p:txBody>
@@ -11946,7 +11586,7 @@
       </p:sp>
       <p:graphicFrame>
         <p:nvGraphicFramePr>
-          <p:cNvPr id="12" name=""/>
+          <p:cNvPr id="14" name=""/>
           <p:cNvGraphicFramePr/>
           <p:nvPr/>
         </p:nvGraphicFramePr>
@@ -13239,7 +12879,7 @@
                 <a:ea typeface="Arial"/>
                 <a:cs typeface="Arial"/>
               </a:rPr>
-              <a:t>Team sizes and tender outcome are from my account. The tender is a team achievement.</a:t>
+              <a:t>Project selection and contribution details are from my account. The outcome belongs to the team.</a:t>
             </a:r>
           </a:p>
         </p:txBody>
@@ -13444,7 +13084,7 @@
         <p:spPr>
           <a:xfrm xmlns:a="http://schemas.openxmlformats.org/drawingml/2006/main">
             <a:off x="609600" y="2457450"/>
-            <a:ext cx="3371850" cy="1200150"/>
+            <a:ext cx="4892040" cy="1200150"/>
           </a:xfrm>
           <a:prstGeom xmlns:a="http://schemas.openxmlformats.org/drawingml/2006/main" prst="rect">
             <a:avLst/>
@@ -13505,7 +13145,7 @@
         <p:spPr>
           <a:xfrm xmlns:a="http://schemas.openxmlformats.org/drawingml/2006/main">
             <a:off x="609600" y="3733800"/>
-            <a:ext cx="3371850" cy="409575"/>
+            <a:ext cx="4892040" cy="409575"/>
           </a:xfrm>
           <a:prstGeom xmlns:a="http://schemas.openxmlformats.org/drawingml/2006/main" prst="rect">
             <a:avLst/>
@@ -13566,7 +13206,7 @@
         <p:spPr>
           <a:xfrm xmlns:a="http://schemas.openxmlformats.org/drawingml/2006/main">
             <a:off x="609600" y="4162425"/>
-            <a:ext cx="3238500" cy="723900"/>
+            <a:ext cx="4754880" cy="723900"/>
           </a:xfrm>
           <a:prstGeom xmlns:a="http://schemas.openxmlformats.org/drawingml/2006/main" prst="rect">
             <a:avLst/>
@@ -13612,22 +13252,22 @@
       </p:sp>
       <p:sp>
         <p:nvSpPr>
-          <p:cNvPr id="10" name="2">
-            <a:extLst xmlns:a="http://schemas.openxmlformats.org/drawingml/2006/main">
-              <a:ext uri="{FF2B5EF4-FFF2-40B4-BE49-F238E27FC236}">
-                <a16:creationId xmlns:a16="http://schemas.microsoft.com/office/drawing/2014/main" id="{DD87EC64-12B6-43BE-8579-0F96F5EC9892}"/>
-              </a:ext>
-            </a:extLst>
-          </p:cNvPr>
-          <p:cNvSpPr>
-            <a:spLocks xmlns:a="http://schemas.openxmlformats.org/drawingml/2006/main" noGrp="1"/>
-          </p:cNvSpPr>
-          <p:nvPr/>
-        </p:nvSpPr>
-        <p:spPr>
-          <a:xfrm xmlns:a="http://schemas.openxmlformats.org/drawingml/2006/main">
-            <a:off x="4352925" y="2457450"/>
-            <a:ext cx="3371850" cy="1200150"/>
+          <p:cNvPr id="13" name="4–5">
+            <a:extLst xmlns:a="http://schemas.openxmlformats.org/drawingml/2006/main">
+              <a:ext uri="{FF2B5EF4-FFF2-40B4-BE49-F238E27FC236}">
+                <a16:creationId xmlns:a16="http://schemas.microsoft.com/office/drawing/2014/main" id="{5CFBF432-5B04-4922-850E-21FA502C55D3}"/>
+              </a:ext>
+            </a:extLst>
+          </p:cNvPr>
+          <p:cNvSpPr>
+            <a:spLocks xmlns:a="http://schemas.openxmlformats.org/drawingml/2006/main" noGrp="1"/>
+          </p:cNvSpPr>
+          <p:nvPr/>
+        </p:nvSpPr>
+        <p:spPr>
+          <a:xfrm xmlns:a="http://schemas.openxmlformats.org/drawingml/2006/main">
+            <a:off x="6345936" y="2457450"/>
+            <a:ext cx="4892040" cy="1200150"/>
           </a:xfrm>
           <a:prstGeom xmlns:a="http://schemas.openxmlformats.org/drawingml/2006/main" prst="rect">
             <a:avLst/>
@@ -13666,29 +13306,29 @@
                 <a:ea typeface="Arial"/>
                 <a:cs typeface="Arial"/>
               </a:rPr>
-              <a:t>2</a:t>
-            </a:r>
-          </a:p>
-        </p:txBody>
-      </p:sp>
-      <p:sp>
-        <p:nvSpPr>
-          <p:cNvPr id="11" name="People per team">
-            <a:extLst xmlns:a="http://schemas.openxmlformats.org/drawingml/2006/main">
-              <a:ext uri="{FF2B5EF4-FFF2-40B4-BE49-F238E27FC236}">
-                <a16:creationId xmlns:a16="http://schemas.microsoft.com/office/drawing/2014/main" id="{DA89ED4A-6637-4769-9D3A-71DA6523344D}"/>
-              </a:ext>
-            </a:extLst>
-          </p:cNvPr>
-          <p:cNvSpPr>
-            <a:spLocks xmlns:a="http://schemas.openxmlformats.org/drawingml/2006/main" noGrp="1"/>
-          </p:cNvSpPr>
-          <p:nvPr/>
-        </p:nvSpPr>
-        <p:spPr>
-          <a:xfrm xmlns:a="http://schemas.openxmlformats.org/drawingml/2006/main">
-            <a:off x="4352925" y="3733800"/>
-            <a:ext cx="3371850" cy="409575"/>
+              <a:t>4–5</a:t>
+            </a:r>
+          </a:p>
+        </p:txBody>
+      </p:sp>
+      <p:sp>
+        <p:nvSpPr>
+          <p:cNvPr id="14" name="Portals researched">
+            <a:extLst xmlns:a="http://schemas.openxmlformats.org/drawingml/2006/main">
+              <a:ext uri="{FF2B5EF4-FFF2-40B4-BE49-F238E27FC236}">
+                <a16:creationId xmlns:a16="http://schemas.microsoft.com/office/drawing/2014/main" id="{CAF7A780-09D6-4D0B-8787-FEB05F8E3A0E}"/>
+              </a:ext>
+            </a:extLst>
+          </p:cNvPr>
+          <p:cNvSpPr>
+            <a:spLocks xmlns:a="http://schemas.openxmlformats.org/drawingml/2006/main" noGrp="1"/>
+          </p:cNvSpPr>
+          <p:nvPr/>
+        </p:nvSpPr>
+        <p:spPr>
+          <a:xfrm xmlns:a="http://schemas.openxmlformats.org/drawingml/2006/main">
+            <a:off x="6345936" y="3733800"/>
+            <a:ext cx="4892040" cy="409575"/>
           </a:xfrm>
           <a:prstGeom xmlns:a="http://schemas.openxmlformats.org/drawingml/2006/main" prst="rect">
             <a:avLst/>
@@ -13727,189 +13367,6 @@
                 <a:ea typeface="Arial"/>
                 <a:cs typeface="Arial"/>
               </a:rPr>
-              <a:t>People per team</a:t>
-            </a:r>
-          </a:p>
-        </p:txBody>
-      </p:sp>
-      <p:sp>
-        <p:nvSpPr>
-          <p:cNvPr id="12" name="RTape and ITMS, including me">
-            <a:extLst xmlns:a="http://schemas.openxmlformats.org/drawingml/2006/main">
-              <a:ext uri="{FF2B5EF4-FFF2-40B4-BE49-F238E27FC236}">
-                <a16:creationId xmlns:a16="http://schemas.microsoft.com/office/drawing/2014/main" id="{0AD2A55E-DE4C-470D-B8AE-421D8D9F53DB}"/>
-              </a:ext>
-            </a:extLst>
-          </p:cNvPr>
-          <p:cNvSpPr>
-            <a:spLocks xmlns:a="http://schemas.openxmlformats.org/drawingml/2006/main" noGrp="1"/>
-          </p:cNvSpPr>
-          <p:nvPr/>
-        </p:nvSpPr>
-        <p:spPr>
-          <a:xfrm xmlns:a="http://schemas.openxmlformats.org/drawingml/2006/main">
-            <a:off x="4352925" y="4162425"/>
-            <a:ext cx="3238500" cy="723900"/>
-          </a:xfrm>
-          <a:prstGeom xmlns:a="http://schemas.openxmlformats.org/drawingml/2006/main" prst="rect">
-            <a:avLst/>
-          </a:prstGeom>
-          <a:noFill xmlns:a="http://schemas.openxmlformats.org/drawingml/2006/main"/>
-          <a:ln xmlns:a="http://schemas.openxmlformats.org/drawingml/2006/main" w="0">
-            <a:noFill/>
-          </a:ln>
-        </p:spPr>
-        <p:txBody>
-          <a:bodyPr xmlns:a="http://schemas.openxmlformats.org/drawingml/2006/main" wrap="square" lIns="0" tIns="0" rIns="0" bIns="0" anchor="t">
-            <a:noAutofit/>
-          </a:bodyPr>
-          <a:lstStyle xmlns:a="http://schemas.openxmlformats.org/drawingml/2006/main"/>
-          <a:p xmlns:a="http://schemas.openxmlformats.org/drawingml/2006/main">
-            <a:pPr algn="l">
-              <a:lnSpc>
-                <a:spcPct val="110000"/>
-              </a:lnSpc>
-              <a:buNone/>
-              <a:defRPr sz="1500" b="0">
-                <a:solidFill>
-                  <a:srgbClr val="56647A"/>
-                </a:solidFill>
-                <a:latin typeface="Arial"/>
-                <a:ea typeface="Arial"/>
-                <a:cs typeface="Arial"/>
-              </a:defRPr>
-            </a:pPr>
-            <a:r>
-              <a:rPr sz="1500" b="0">
-                <a:solidFill>
-                  <a:srgbClr val="56647A"/>
-                </a:solidFill>
-                <a:latin typeface="Arial"/>
-                <a:ea typeface="Arial"/>
-                <a:cs typeface="Arial"/>
-              </a:rPr>
-              <a:t>RTape and ITMS, including me</a:t>
-            </a:r>
-          </a:p>
-        </p:txBody>
-      </p:sp>
-      <p:sp>
-        <p:nvSpPr>
-          <p:cNvPr id="13" name="4–5">
-            <a:extLst xmlns:a="http://schemas.openxmlformats.org/drawingml/2006/main">
-              <a:ext uri="{FF2B5EF4-FFF2-40B4-BE49-F238E27FC236}">
-                <a16:creationId xmlns:a16="http://schemas.microsoft.com/office/drawing/2014/main" id="{5CFBF432-5B04-4922-850E-21FA502C55D3}"/>
-              </a:ext>
-            </a:extLst>
-          </p:cNvPr>
-          <p:cNvSpPr>
-            <a:spLocks xmlns:a="http://schemas.openxmlformats.org/drawingml/2006/main" noGrp="1"/>
-          </p:cNvSpPr>
-          <p:nvPr/>
-        </p:nvSpPr>
-        <p:spPr>
-          <a:xfrm xmlns:a="http://schemas.openxmlformats.org/drawingml/2006/main">
-            <a:off x="8096250" y="2457450"/>
-            <a:ext cx="3371850" cy="1200150"/>
-          </a:xfrm>
-          <a:prstGeom xmlns:a="http://schemas.openxmlformats.org/drawingml/2006/main" prst="rect">
-            <a:avLst/>
-          </a:prstGeom>
-          <a:noFill xmlns:a="http://schemas.openxmlformats.org/drawingml/2006/main"/>
-          <a:ln xmlns:a="http://schemas.openxmlformats.org/drawingml/2006/main" w="0">
-            <a:noFill/>
-          </a:ln>
-        </p:spPr>
-        <p:txBody>
-          <a:bodyPr xmlns:a="http://schemas.openxmlformats.org/drawingml/2006/main" wrap="square" lIns="0" tIns="0" rIns="0" bIns="0" anchor="t">
-            <a:noAutofit/>
-          </a:bodyPr>
-          <a:lstStyle xmlns:a="http://schemas.openxmlformats.org/drawingml/2006/main"/>
-          <a:p xmlns:a="http://schemas.openxmlformats.org/drawingml/2006/main">
-            <a:pPr algn="l">
-              <a:lnSpc>
-                <a:spcPct val="110000"/>
-              </a:lnSpc>
-              <a:buNone/>
-              <a:defRPr sz="7500" b="1">
-                <a:solidFill>
-                  <a:srgbClr val="245EE8"/>
-                </a:solidFill>
-                <a:latin typeface="Arial"/>
-                <a:ea typeface="Arial"/>
-                <a:cs typeface="Arial"/>
-              </a:defRPr>
-            </a:pPr>
-            <a:r>
-              <a:rPr sz="7500" b="1">
-                <a:solidFill>
-                  <a:srgbClr val="245EE8"/>
-                </a:solidFill>
-                <a:latin typeface="Arial"/>
-                <a:ea typeface="Arial"/>
-                <a:cs typeface="Arial"/>
-              </a:rPr>
-              <a:t>4–5</a:t>
-            </a:r>
-          </a:p>
-        </p:txBody>
-      </p:sp>
-      <p:sp>
-        <p:nvSpPr>
-          <p:cNvPr id="14" name="Portals researched">
-            <a:extLst xmlns:a="http://schemas.openxmlformats.org/drawingml/2006/main">
-              <a:ext uri="{FF2B5EF4-FFF2-40B4-BE49-F238E27FC236}">
-                <a16:creationId xmlns:a16="http://schemas.microsoft.com/office/drawing/2014/main" id="{CAF7A780-09D6-4D0B-8787-FEB05F8E3A0E}"/>
-              </a:ext>
-            </a:extLst>
-          </p:cNvPr>
-          <p:cNvSpPr>
-            <a:spLocks xmlns:a="http://schemas.openxmlformats.org/drawingml/2006/main" noGrp="1"/>
-          </p:cNvSpPr>
-          <p:nvPr/>
-        </p:nvSpPr>
-        <p:spPr>
-          <a:xfrm xmlns:a="http://schemas.openxmlformats.org/drawingml/2006/main">
-            <a:off x="8096250" y="3733800"/>
-            <a:ext cx="3371850" cy="409575"/>
-          </a:xfrm>
-          <a:prstGeom xmlns:a="http://schemas.openxmlformats.org/drawingml/2006/main" prst="rect">
-            <a:avLst/>
-          </a:prstGeom>
-          <a:noFill xmlns:a="http://schemas.openxmlformats.org/drawingml/2006/main"/>
-          <a:ln xmlns:a="http://schemas.openxmlformats.org/drawingml/2006/main" w="0">
-            <a:noFill/>
-          </a:ln>
-        </p:spPr>
-        <p:txBody>
-          <a:bodyPr xmlns:a="http://schemas.openxmlformats.org/drawingml/2006/main" wrap="square" lIns="0" tIns="0" rIns="0" bIns="0" anchor="t">
-            <a:noAutofit/>
-          </a:bodyPr>
-          <a:lstStyle xmlns:a="http://schemas.openxmlformats.org/drawingml/2006/main"/>
-          <a:p xmlns:a="http://schemas.openxmlformats.org/drawingml/2006/main">
-            <a:pPr algn="l">
-              <a:lnSpc>
-                <a:spcPct val="110000"/>
-              </a:lnSpc>
-              <a:buNone/>
-              <a:defRPr sz="1875" b="1">
-                <a:solidFill>
-                  <a:srgbClr val="142137"/>
-                </a:solidFill>
-                <a:latin typeface="Arial"/>
-                <a:ea typeface="Arial"/>
-                <a:cs typeface="Arial"/>
-              </a:defRPr>
-            </a:pPr>
-            <a:r>
-              <a:rPr sz="1875" b="1">
-                <a:solidFill>
-                  <a:srgbClr val="142137"/>
-                </a:solidFill>
-                <a:latin typeface="Arial"/>
-                <a:ea typeface="Arial"/>
-                <a:cs typeface="Arial"/>
-              </a:rPr>
               <a:t>Portals researched</a:t>
             </a:r>
           </a:p>
@@ -13931,8 +13388,8 @@
         </p:nvSpPr>
         <p:spPr>
           <a:xfrm xmlns:a="http://schemas.openxmlformats.org/drawingml/2006/main">
-            <a:off x="8096250" y="4162425"/>
-            <a:ext cx="3238500" cy="723900"/>
+            <a:off x="6345936" y="4162425"/>
+            <a:ext cx="4754880" cy="723900"/>
           </a:xfrm>
           <a:prstGeom xmlns:a="http://schemas.openxmlformats.org/drawingml/2006/main" prst="rect">
             <a:avLst/>
@@ -14005,6 +13462,10 @@
             </a:solidFill>
           </a:ln>
         </p:spPr>
+        <p:txBody xmlns:a="http://schemas.openxmlformats.org/drawingml/2006/main">
+          <a:bodyPr/>
+          <a:p/>
+        </p:txBody>
       </p:sp>
       <p:sp>
         <p:nvSpPr>
@@ -14062,7 +13523,7 @@
                 <a:ea typeface="Arial"/>
                 <a:cs typeface="Arial"/>
               </a:rPr>
-              <a:t>RTape secured a government tender following the team’s development and demonstration effort.</a:t>
+              <a:t>RTape was selected for state-level deployment in Madhya Pradesh.</a:t>
             </a:r>
           </a:p>
         </p:txBody>
@@ -14974,7 +14435,7 @@
                 <a:ea typeface="Arial"/>
                 <a:cs typeface="Arial"/>
               </a:rPr>
-              <a:t>Planned the frontend architecture and built operational features end to end.</a:t>
+              <a:t>Built the entire frontend from scratch, from architecture through delivery.</a:t>
             </a:r>
           </a:p>
         </p:txBody>
@@ -15065,7 +14526,7 @@
                 <a:ea typeface="Arial"/>
                 <a:cs typeface="Arial"/>
               </a:rPr>
-              <a:t>System design and permission-heavy workflows</a:t>
+              <a:t>Sole frontend ownership and end-to-end execution</a:t>
             </a:r>
           </a:p>
         </p:txBody>
@@ -15278,7 +14739,7 @@
                 <a:ea typeface="Arial"/>
                 <a:cs typeface="Arial"/>
               </a:rPr>
-              <a:t>Improved the architecture while supporting a growing frontend team.</a:t>
+              <a:t>Lead the three-person frontend team while owning major modules.</a:t>
             </a:r>
           </a:p>
         </p:txBody>
@@ -15369,7 +14830,7 @@
                 <a:ea typeface="Arial"/>
                 <a:cs typeface="Arial"/>
               </a:rPr>
-              <a:t>Requirements, mentoring and technical guidance</a:t>
+              <a:t>Planning, workflow alignment, mentoring and issue resolution</a:t>
             </a:r>
           </a:p>
         </p:txBody>
@@ -15977,7 +15438,7 @@
                 <a:ea typeface="Arial"/>
                 <a:cs typeface="Arial"/>
               </a:rPr>
-              <a:t>Built with one backend teammate, with guidance from Ritesh sir.</a:t>
+              <a:t>Built with one backend teammate, with guidance from the team lead.</a:t>
             </a:r>
           </a:p>
         </p:txBody>
@@ -17740,7 +17201,7 @@
                 <a:ea typeface="Arial"/>
                 <a:cs typeface="Arial"/>
               </a:rPr>
-              <a:t>Tender outcome and demonstration details are reported in my account.</a:t>
+              <a:t>Project selection and demonstration details are reported in my account.</a:t>
             </a:r>
           </a:p>
         </p:txBody>
@@ -17976,7 +17437,7 @@
               </a:defRPr>
             </a:pPr>
             <a:r>
-              <a:rPr sz="4875" b="1">
+              <a:rPr sz="3200" b="1">
                 <a:solidFill>
                   <a:srgbClr val="245EE8"/>
                 </a:solidFill>
@@ -17984,7 +17445,7 @@
                 <a:ea typeface="Arial"/>
                 <a:cs typeface="Arial"/>
               </a:rPr>
-              <a:t>Government</a:t>
+              <a:t>Project selected</a:t>
             </a:r>
           </a:p>
           <a:p xmlns:a="http://schemas.openxmlformats.org/drawingml/2006/main">
@@ -18003,7 +17464,7 @@
               </a:defRPr>
             </a:pPr>
             <a:r>
-              <a:rPr sz="4875" b="1">
+              <a:rPr sz="3200" b="1">
                 <a:solidFill>
                   <a:srgbClr val="245EE8"/>
                 </a:solidFill>
@@ -18011,7 +17472,61 @@
                 <a:ea typeface="Arial"/>
                 <a:cs typeface="Arial"/>
               </a:rPr>
-              <a:t>tender won</a:t>
+              <a:t>for state-level</a:t>
+            </a:r>
+          </a:p>
+          <a:p xmlns:a="http://schemas.openxmlformats.org/drawingml/2006/main">
+            <a:pPr algn="l">
+              <a:lnSpc>
+                <a:spcPct val="110000"/>
+              </a:lnSpc>
+              <a:buNone/>
+              <a:defRPr sz="4875" b="1">
+                <a:solidFill>
+                  <a:srgbClr val="245EE8"/>
+                </a:solidFill>
+                <a:latin typeface="Arial"/>
+                <a:ea typeface="Arial"/>
+                <a:cs typeface="Arial"/>
+              </a:defRPr>
+            </a:pPr>
+            <a:r>
+              <a:rPr sz="3200" b="1">
+                <a:solidFill>
+                  <a:srgbClr val="245EE8"/>
+                </a:solidFill>
+                <a:latin typeface="Arial"/>
+                <a:ea typeface="Arial"/>
+                <a:cs typeface="Arial"/>
+              </a:rPr>
+              <a:t>deployment in</a:t>
+            </a:r>
+          </a:p>
+          <a:p xmlns:a="http://schemas.openxmlformats.org/drawingml/2006/main">
+            <a:pPr algn="l">
+              <a:lnSpc>
+                <a:spcPct val="110000"/>
+              </a:lnSpc>
+              <a:buNone/>
+              <a:defRPr sz="4875" b="1">
+                <a:solidFill>
+                  <a:srgbClr val="245EE8"/>
+                </a:solidFill>
+                <a:latin typeface="Arial"/>
+                <a:ea typeface="Arial"/>
+                <a:cs typeface="Arial"/>
+              </a:defRPr>
+            </a:pPr>
+            <a:r>
+              <a:rPr sz="3200" b="1">
+                <a:solidFill>
+                  <a:srgbClr val="245EE8"/>
+                </a:solidFill>
+                <a:latin typeface="Arial"/>
+                <a:ea typeface="Arial"/>
+                <a:cs typeface="Arial"/>
+              </a:rPr>
+              <a:t>Madhya Pradesh</a:t>
             </a:r>
           </a:p>
         </p:txBody>
@@ -18467,7 +17982,7 @@
                 <a:ea typeface="Arial"/>
                 <a:cs typeface="Arial"/>
               </a:rPr>
-              <a:t>Supported Ritesh sir during the Madhya Pradesh demonstration.</a:t>
+              <a:t>Supported the team lead during the Madhya Pradesh demonstration.</a:t>
             </a:r>
           </a:p>
         </p:txBody>
@@ -18960,67 +18475,6 @@
       </p:sp>
       <p:sp>
         <p:nvSpPr>
-          <p:cNvPr id="6" name="Activity attributed to Manish Kumar in the supplied repository re">
-            <a:extLst xmlns:a="http://schemas.openxmlformats.org/drawingml/2006/main">
-              <a:ext uri="{FF2B5EF4-FFF2-40B4-BE49-F238E27FC236}">
-                <a16:creationId xmlns:a16="http://schemas.microsoft.com/office/drawing/2014/main" id="{C895FB78-53AE-43C0-A2A7-734CC5156D45}"/>
-              </a:ext>
-            </a:extLst>
-          </p:cNvPr>
-          <p:cNvSpPr>
-            <a:spLocks xmlns:a="http://schemas.openxmlformats.org/drawingml/2006/main" noGrp="1"/>
-          </p:cNvSpPr>
-          <p:nvPr/>
-        </p:nvSpPr>
-        <p:spPr>
-          <a:xfrm xmlns:a="http://schemas.openxmlformats.org/drawingml/2006/main">
-            <a:off x="609600" y="1571625"/>
-            <a:ext cx="10858500" cy="342900"/>
-          </a:xfrm>
-          <a:prstGeom xmlns:a="http://schemas.openxmlformats.org/drawingml/2006/main" prst="rect">
-            <a:avLst/>
-          </a:prstGeom>
-          <a:noFill xmlns:a="http://schemas.openxmlformats.org/drawingml/2006/main"/>
-          <a:ln xmlns:a="http://schemas.openxmlformats.org/drawingml/2006/main" w="0">
-            <a:noFill/>
-          </a:ln>
-        </p:spPr>
-        <p:txBody>
-          <a:bodyPr xmlns:a="http://schemas.openxmlformats.org/drawingml/2006/main" wrap="square" lIns="0" tIns="0" rIns="0" bIns="0" anchor="t">
-            <a:noAutofit/>
-          </a:bodyPr>
-          <a:lstStyle xmlns:a="http://schemas.openxmlformats.org/drawingml/2006/main"/>
-          <a:p xmlns:a="http://schemas.openxmlformats.org/drawingml/2006/main">
-            <a:pPr algn="l">
-              <a:lnSpc>
-                <a:spcPct val="110000"/>
-              </a:lnSpc>
-              <a:buNone/>
-              <a:defRPr sz="1725" b="0">
-                <a:solidFill>
-                  <a:srgbClr val="56647A"/>
-                </a:solidFill>
-                <a:latin typeface="Arial"/>
-                <a:ea typeface="Arial"/>
-                <a:cs typeface="Arial"/>
-              </a:defRPr>
-            </a:pPr>
-            <a:r>
-              <a:rPr sz="1725" b="0">
-                <a:solidFill>
-                  <a:srgbClr val="56647A"/>
-                </a:solidFill>
-                <a:latin typeface="Arial"/>
-                <a:ea typeface="Arial"/>
-                <a:cs typeface="Arial"/>
-              </a:rPr>
-              <a:t>Activity attributed to Manish Kumar in the supplied repository review</a:t>
-            </a:r>
-          </a:p>
-        </p:txBody>
-      </p:sp>
-      <p:sp>
-        <p:nvSpPr>
           <p:cNvPr id="7" name="280">
             <a:extLst xmlns:a="http://schemas.openxmlformats.org/drawingml/2006/main">
               <a:ext uri="{FF2B5EF4-FFF2-40B4-BE49-F238E27FC236}">
@@ -19988,7 +19442,7 @@
                 <a:ea typeface="Arial"/>
                 <a:cs typeface="Arial"/>
               </a:rPr>
-              <a:t>Architecture and delivery</a:t>
+              <a:t>The complete frontend,</a:t>
             </a:r>
           </a:p>
           <a:p xmlns:a="http://schemas.openxmlformats.org/drawingml/2006/main">
@@ -20015,7 +19469,7 @@
                 <a:ea typeface="Arial"/>
                 <a:cs typeface="Arial"/>
               </a:rPr>
-              <a:t>for transport operations</a:t>
+              <a:t>built from scratch</a:t>
             </a:r>
           </a:p>
         </p:txBody>
@@ -20076,7 +19530,7 @@
                 <a:ea typeface="Arial"/>
                 <a:cs typeface="Arial"/>
               </a:rPr>
-              <a:t>A multi-role bus management frontend built by a two-member team</a:t>
+              <a:t>A multi-role bus management platform with sole frontend ownership</a:t>
             </a:r>
           </a:p>
         </p:txBody>
@@ -20137,7 +19591,7 @@
                 <a:ea typeface="Arial"/>
                 <a:cs typeface="Arial"/>
               </a:rPr>
-              <a:t>I planned the frontend and worked on features end to end.</a:t>
+              <a:t>I planned and built the entire frontend from the ground up.</a:t>
             </a:r>
           </a:p>
         </p:txBody>
@@ -20472,7 +19926,7 @@
                 <a:ea typeface="Arial"/>
                 <a:cs typeface="Arial"/>
               </a:rPr>
-              <a:t>Role-specific operations</a:t>
+              <a:t>End-to-end delivery</a:t>
             </a:r>
           </a:p>
         </p:txBody>
@@ -20533,7 +19987,7 @@
                 <a:ea typeface="Arial"/>
                 <a:cs typeface="Arial"/>
               </a:rPr>
-              <a:t>Built permission-heavy workflows for different transport users.</a:t>
+              <a:t>Implemented role-specific operational workflows across the complete frontend.</a:t>
             </a:r>
           </a:p>
         </p:txBody>

</xml_diff>